<commit_message>
Testbed slides: thresholds and values instead of margins
Co-Authored-By: Claude Fable 5.1 <noreply@anthropic.com>
Claude-Session: https://claude.ai/code/session_01GMyoeW1mH61xWENeXtab1u
</commit_message>
<xml_diff>
--- a/scoop_testbed_paper/SCooP-iT_testbed_questions.pptx
+++ b/scoop_testbed_paper/SCooP-iT_testbed_questions.pptx
@@ -2917,7 +2917,7 @@
                 <a:ea typeface="Arial" pitchFamily="34" charset="-122"/>
                 <a:cs typeface="Arial" pitchFamily="34" charset="-120"/>
               </a:rPr>
-              <a:t>1.5 MB messages at 10 Hz through the logged link against the synthetic channels of prior benchmarks; demonstration</a:t>
+              <a:t>1.5 MB messages at 10 Hz through the logged link against the synthetic channels of prior benchmarks</a:t>
             </a:r>
             <a:endParaRPr lang="en-US" sz="1200" dirty="0"/>
           </a:p>
@@ -2946,9 +2946,9 @@
             <a:tbl>
               <a:tblPr/>
               <a:tblGrid>
-                <a:gridCol w="2468880"/>
-                <a:gridCol w="2743200"/>
-                <a:gridCol w="2834640"/>
+                <a:gridCol w="3657600"/>
+                <a:gridCol w="1737360"/>
+                <a:gridCol w="2651760"/>
               </a:tblGrid>
               <a:tr h="210312">
                 <a:tc>
@@ -3010,7 +3010,7 @@
                           <a:ea typeface="Arial" pitchFamily="34" charset="-122"/>
                           <a:cs typeface="Arial" pitchFamily="34" charset="-120"/>
                         </a:rPr>
-                        <a:t>Quantity</a:t>
+                        <a:t>Reference</a:t>
                       </a:r>
                       <a:endParaRPr lang="en-US" sz="1100" dirty="0">
                         <a:latin typeface="Arial" charset="0"/>
@@ -3118,7 +3118,7 @@
                           <a:ea typeface="Arial" pitchFamily="34" charset="-122"/>
                           <a:cs typeface="Arial" pitchFamily="34" charset="-120"/>
                         </a:rPr>
-                        <a:t>Share arriving within one LiDAR frame</a:t>
+                        <a:t>Share arriving within one LiDAR frame (100 ms)</a:t>
                       </a:r>
                       <a:endParaRPr lang="en-US" sz="1100" dirty="0">
                         <a:latin typeface="Arial" charset="0"/>
@@ -3167,7 +3167,7 @@
                           <a:ea typeface="Arial" pitchFamily="34" charset="-122"/>
                           <a:cs typeface="Arial" pitchFamily="34" charset="-120"/>
                         </a:rPr>
-                        <a:t>      One robot</a:t>
+                        <a:t>      One robot (survey_1)</a:t>
                       </a:r>
                       <a:endParaRPr lang="en-US" sz="1100" dirty="0">
                         <a:latin typeface="Arial" charset="0"/>
@@ -3208,7 +3208,7 @@
                           <a:ea typeface="Arial" pitchFamily="34" charset="-122"/>
                           <a:cs typeface="Arial" pitchFamily="34" charset="-120"/>
                         </a:rPr>
-                        <a:t>survey_1</a:t>
+                        <a:t>100 % synthetic</a:t>
                       </a:r>
                       <a:endParaRPr lang="en-US" sz="1100" dirty="0">
                         <a:latin typeface="Arial" charset="0"/>
@@ -3292,7 +3292,7 @@
                           <a:ea typeface="Arial" pitchFamily="34" charset="-122"/>
                           <a:cs typeface="Arial" pitchFamily="34" charset="-120"/>
                         </a:rPr>
-                        <a:t>      Two robots contending</a:t>
+                        <a:t>      Two robots contending (coop_2)</a:t>
                       </a:r>
                       <a:endParaRPr lang="en-US" sz="1100" dirty="0">
                         <a:latin typeface="Arial" charset="0"/>
@@ -3333,7 +3333,7 @@
                           <a:ea typeface="Arial" pitchFamily="34" charset="-122"/>
                           <a:cs typeface="Arial" pitchFamily="34" charset="-120"/>
                         </a:rPr>
-                        <a:t>coop_2</a:t>
+                        <a:t>100 % synthetic</a:t>
                       </a:r>
                       <a:endParaRPr lang="en-US" sz="1100" dirty="0">
                         <a:latin typeface="Arial" charset="0"/>
@@ -3417,7 +3417,7 @@
                           <a:ea typeface="Arial" pitchFamily="34" charset="-122"/>
                           <a:cs typeface="Arial" pitchFamily="34" charset="-120"/>
                         </a:rPr>
-                        <a:t>      Synthetic channels</a:t>
+                        <a:t>      Synthetic: V2X-ViT 100 ms; Where2comm none</a:t>
                       </a:r>
                       <a:endParaRPr lang="en-US" sz="1100" dirty="0">
                         <a:latin typeface="Arial" charset="0"/>
@@ -3449,17 +3449,6 @@
                       <a:pPr indent="0" marL="0">
                         <a:buNone/>
                       </a:pPr>
-                      <a:r>
-                        <a:rPr lang="en-US" sz="1100" dirty="0">
-                          <a:solidFill>
-                            <a:srgbClr val="444444"/>
-                          </a:solidFill>
-                          <a:latin typeface="Arial" pitchFamily="34" charset="0"/>
-                          <a:ea typeface="Arial" pitchFamily="34" charset="-122"/>
-                          <a:cs typeface="Arial" pitchFamily="34" charset="-120"/>
-                        </a:rPr>
-                        <a:t>V2X-ViT 100 ms; Where2comm none</a:t>
-                      </a:r>
                       <a:endParaRPr lang="en-US" sz="1100" dirty="0">
                         <a:latin typeface="Arial" charset="0"/>
                         <a:ea typeface="Arial" charset="0"/>
@@ -3591,7 +3580,7 @@
                           <a:ea typeface="Arial" pitchFamily="34" charset="-122"/>
                           <a:cs typeface="Arial" pitchFamily="34" charset="-120"/>
                         </a:rPr>
-                        <a:t>      RTT idle to loaded</a:t>
+                        <a:t>      RTT idle to loaded (coop_2)</a:t>
                       </a:r>
                       <a:endParaRPr lang="en-US" sz="1100" dirty="0">
                         <a:latin typeface="Arial" charset="0"/>
@@ -3632,7 +3621,7 @@
                           <a:ea typeface="Arial" pitchFamily="34" charset="-122"/>
                           <a:cs typeface="Arial" pitchFamily="34" charset="-120"/>
                         </a:rPr>
-                        <a:t>coop_2</a:t>
+                        <a:t>100 ms frame</a:t>
                       </a:r>
                       <a:endParaRPr lang="en-US" sz="1100" dirty="0">
                         <a:latin typeface="Arial" charset="0"/>
@@ -3716,7 +3705,7 @@
                           <a:ea typeface="Arial" pitchFamily="34" charset="-122"/>
                           <a:cs typeface="Arial" pitchFamily="34" charset="-120"/>
                         </a:rPr>
-                        <a:t>      Real outages</a:t>
+                        <a:t>      Real outages (coop2_0828)</a:t>
                       </a:r>
                       <a:endParaRPr lang="en-US" sz="1100" dirty="0">
                         <a:latin typeface="Arial" charset="0"/>
@@ -3757,7 +3746,7 @@
                           <a:ea typeface="Arial" pitchFamily="34" charset="-122"/>
                           <a:cs typeface="Arial" pitchFamily="34" charset="-120"/>
                         </a:rPr>
-                        <a:t>coop2_0828</a:t>
+                        <a:t>none in synthetic</a:t>
                       </a:r>
                       <a:endParaRPr lang="en-US" sz="1100" dirty="0">
                         <a:latin typeface="Arial" charset="0"/>
@@ -3890,7 +3879,7 @@
                           <a:ea typeface="Arial" pitchFamily="34" charset="-122"/>
                           <a:cs typeface="Arial" pitchFamily="34" charset="-120"/>
                         </a:rPr>
-                        <a:t>      Best-fit synthetic baseline</a:t>
+                        <a:t>      Best-fit synthetic baseline, fitted delay</a:t>
                       </a:r>
                       <a:endParaRPr lang="en-US" sz="1100" dirty="0">
                         <a:latin typeface="Arial" charset="0"/>
@@ -3931,7 +3920,7 @@
                           <a:ea typeface="Arial" pitchFamily="34" charset="-122"/>
                           <a:cs typeface="Arial" pitchFamily="34" charset="-120"/>
                         </a:rPr>
-                        <a:t>constant or Binomial delay fitted</a:t>
+                        <a:t>in-frame share</a:t>
                       </a:r>
                       <a:endParaRPr lang="en-US" sz="1100" dirty="0">
                         <a:latin typeface="Arial" charset="0"/>
@@ -4047,17 +4036,6 @@
                       <a:pPr indent="0" marL="0">
                         <a:buNone/>
                       </a:pPr>
-                      <a:r>
-                        <a:rPr lang="en-US" sz="1100" dirty="0">
-                          <a:solidFill>
-                            <a:srgbClr val="444444"/>
-                          </a:solidFill>
-                          <a:latin typeface="Arial" pitchFamily="34" charset="0"/>
-                          <a:ea typeface="Arial" pitchFamily="34" charset="-122"/>
-                          <a:cs typeface="Arial" pitchFamily="34" charset="-120"/>
-                        </a:rPr>
-                        <a:t>sim_gap.py</a:t>
-                      </a:r>
                       <a:endParaRPr lang="en-US" sz="1100" dirty="0">
                         <a:latin typeface="Arial" charset="0"/>
                         <a:ea typeface="Arial" charset="0"/>
@@ -4140,7 +4118,7 @@
                           <a:ea typeface="Arial" pitchFamily="34" charset="-122"/>
                           <a:cs typeface="Arial" pitchFamily="34" charset="-120"/>
                         </a:rPr>
-                        <a:t>      Probe-off control run</a:t>
+                        <a:t>      Probe-off control run (ping only)</a:t>
                       </a:r>
                       <a:endParaRPr lang="en-US" sz="1100" dirty="0">
                         <a:latin typeface="Arial" charset="0"/>
@@ -4178,17 +4156,6 @@
                       <a:pPr indent="0" marL="0">
                         <a:buNone/>
                       </a:pPr>
-                      <a:r>
-                        <a:rPr lang="en-US" sz="1100" dirty="0">
-                          <a:solidFill>
-                            <a:srgbClr val="444444"/>
-                          </a:solidFill>
-                          <a:latin typeface="Arial" pitchFamily="34" charset="0"/>
-                          <a:ea typeface="Arial" pitchFamily="34" charset="-122"/>
-                          <a:cs typeface="Arial" pitchFamily="34" charset="-120"/>
-                        </a:rPr>
-                        <a:t>ping only, no iperf</a:t>
-                      </a:r>
                       <a:endParaRPr lang="en-US" sz="1100" dirty="0">
                         <a:latin typeface="Arial" charset="0"/>
                         <a:ea typeface="Arial" charset="0"/>
@@ -6910,7 +6877,7 @@
                           <a:ea typeface="Arial" pitchFamily="34" charset="-122"/>
                           <a:cs typeface="Arial" pitchFamily="34" charset="-120"/>
                         </a:rPr>
-                        <a:t>clock 0.99 ms (101x); map 0.15 / 1.06 cm; detector 8 mm; cart 3.1 cm; LiDAR robot 10 mm</a:t>
+                        <a:t>clock 0.99 ms; map 0.15 / 1.06 cm; detector 8 mm; cart 3.1 cm; LiDAR robot 10 mm</a:t>
                       </a:r>
                       <a:endParaRPr lang="en-US" sz="1100" dirty="0">
                         <a:latin typeface="Arial" charset="0"/>
@@ -8922,7 +8889,7 @@
                 <a:ea typeface="Arial" pitchFamily="34" charset="-122"/>
                 <a:cs typeface="Arial" pitchFamily="34" charset="-120"/>
               </a:rPr>
-              <a:t>If clock or pose errors were as coarse as the effects under study, every later number would be ambiguous. Pass: each term 10x below the breaking point of its kind (0.2 m pose; one LiDAR frame for time)</a:t>
+              <a:t>If clock or pose errors were as coarse as the effects under study, every later number would be ambiguous. Thresholds: a tenth of where fusion breaks, 2 cm for pose terms, 10 ms for time terms</a:t>
             </a:r>
             <a:endParaRPr lang="en-US" sz="1700" dirty="0"/>
           </a:p>
@@ -8985,7 +8952,7 @@
                 <a:ea typeface="Arial" pitchFamily="34" charset="-122"/>
                 <a:cs typeface="Arial" pitchFamily="34" charset="-120"/>
               </a:rPr>
-              <a:t>Answer: 0.99 ms measured = 1 mm, 101x below one frame; strict bound 12 ms = 1.2 cm, 8x (short)</a:t>
+              <a:t>Answer: 0.99 ms measured, under the 10 ms threshold; strict bound 12 ms, above it</a:t>
             </a:r>
             <a:endParaRPr lang="en-US" sz="1700" dirty="0"/>
           </a:p>
@@ -9048,7 +9015,7 @@
                 <a:ea typeface="Arial" pitchFamily="34" charset="-122"/>
                 <a:cs typeface="Arial" pitchFamily="34" charset="-120"/>
               </a:rPr>
-              <a:t>Answer: RGB-D cart 3.1 cm median (6.5x below 0.2 m, short of 10x); LiDAR robot 10 mm (coop2_0828); map repeats to 1.06 cm</a:t>
+              <a:t>Answer: RGB-D cart 3.1 cm median, above the 2 cm threshold; LiDAR robot 10 mm (coop2_0828); map repeats to 1.06 cm</a:t>
             </a:r>
             <a:endParaRPr lang="en-US" sz="1700" dirty="0"/>
           </a:p>
@@ -9268,7 +9235,7 @@
                 <a:ea typeface="Arial" pitchFamily="34" charset="-122"/>
                 <a:cs typeface="Arial" pitchFamily="34" charset="-120"/>
               </a:rPr>
-              <a:t>Each term against the breaking point of its kind: 0.2 m for pose, one LiDAR frame (0.1 m at 1 m/s) for time; pass at 10x</a:t>
+              <a:t>Thresholds are a tenth of where fusion breaks: 2 cm for pose terms (0.2 m), 10 ms for time terms (one LiDAR frame)</a:t>
             </a:r>
             <a:endParaRPr lang="en-US" sz="1200" dirty="0"/>
           </a:p>
@@ -9297,9 +9264,9 @@
             <a:tbl>
               <a:tblPr/>
               <a:tblGrid>
-                <a:gridCol w="2468880"/>
-                <a:gridCol w="2743200"/>
-                <a:gridCol w="2834640"/>
+                <a:gridCol w="3566160"/>
+                <a:gridCol w="1371600"/>
+                <a:gridCol w="3108960"/>
               </a:tblGrid>
               <a:tr h="210312">
                 <a:tc>
@@ -9361,7 +9328,7 @@
                           <a:ea typeface="Arial" pitchFamily="34" charset="-122"/>
                           <a:cs typeface="Arial" pitchFamily="34" charset="-120"/>
                         </a:rPr>
-                        <a:t>Quantity</a:t>
+                        <a:t>Threshold</a:t>
                       </a:r>
                       <a:endParaRPr lang="en-US" sz="1100" dirty="0">
                         <a:latin typeface="Arial" charset="0"/>
@@ -9518,7 +9485,7 @@
                           <a:ea typeface="Arial" pitchFamily="34" charset="-122"/>
                           <a:cs typeface="Arial" pitchFamily="34" charset="-120"/>
                         </a:rPr>
-                        <a:t>      Measured offset</a:t>
+                        <a:t>      Measured offset (coop_2)</a:t>
                       </a:r>
                       <a:endParaRPr lang="en-US" sz="1100" dirty="0">
                         <a:latin typeface="Arial" charset="0"/>
@@ -9559,7 +9526,7 @@
                           <a:ea typeface="Arial" pitchFamily="34" charset="-122"/>
                           <a:cs typeface="Arial" pitchFamily="34" charset="-120"/>
                         </a:rPr>
-                        <a:t>coop_2, chrony logs</a:t>
+                        <a:t>10 ms</a:t>
                       </a:r>
                       <a:endParaRPr lang="en-US" sz="1100" dirty="0">
                         <a:latin typeface="Arial" charset="0"/>
@@ -9600,7 +9567,7 @@
                           <a:ea typeface="Arial" pitchFamily="34" charset="-122"/>
                           <a:cs typeface="Arial" pitchFamily="34" charset="-120"/>
                         </a:rPr>
-                        <a:t>0.99 ms = 1 mm (101x)</a:t>
+                        <a:t>0.99 ms</a:t>
                       </a:r>
                       <a:endParaRPr lang="en-US" sz="1100" dirty="0">
                         <a:latin typeface="Arial" charset="0"/>
@@ -9643,7 +9610,7 @@
                           <a:ea typeface="Arial" pitchFamily="34" charset="-122"/>
                           <a:cs typeface="Arial" pitchFamily="34" charset="-120"/>
                         </a:rPr>
-                        <a:t>      Strict chrony bound</a:t>
+                        <a:t>      Strict chrony bound (coop_2)</a:t>
                       </a:r>
                       <a:endParaRPr lang="en-US" sz="1100" dirty="0">
                         <a:latin typeface="Arial" charset="0"/>
@@ -9684,7 +9651,7 @@
                           <a:ea typeface="Arial" pitchFamily="34" charset="-122"/>
                           <a:cs typeface="Arial" pitchFamily="34" charset="-120"/>
                         </a:rPr>
-                        <a:t>coop_2, offset + root delay/2</a:t>
+                        <a:t>10 ms</a:t>
                       </a:r>
                       <a:endParaRPr lang="en-US" sz="1100" dirty="0">
                         <a:latin typeface="Arial" charset="0"/>
@@ -9725,7 +9692,7 @@
                           <a:ea typeface="Arial" pitchFamily="34" charset="-122"/>
                           <a:cs typeface="Arial" pitchFamily="34" charset="-120"/>
                         </a:rPr>
-                        <a:t>12 ms = 1.2 cm (8.3x)</a:t>
+                        <a:t>12 ms</a:t>
                       </a:r>
                       <a:endParaRPr lang="en-US" sz="1100" dirty="0">
                         <a:latin typeface="Arial" charset="0"/>
@@ -9768,7 +9735,7 @@
                           <a:ea typeface="Arial" pitchFamily="34" charset="-122"/>
                           <a:cs typeface="Arial" pitchFamily="34" charset="-120"/>
                         </a:rPr>
-                        <a:t>      Sniffer bias</a:t>
+                        <a:t>      Sniffer bias (probe stamps)</a:t>
                       </a:r>
                       <a:endParaRPr lang="en-US" sz="1100" dirty="0">
                         <a:latin typeface="Arial" charset="0"/>
@@ -9809,7 +9776,7 @@
                           <a:ea typeface="Arial" pitchFamily="34" charset="-122"/>
                           <a:cs typeface="Arial" pitchFamily="34" charset="-120"/>
                         </a:rPr>
-                        <a:t>probe stamps, both ends</a:t>
+                        <a:t>10 ms</a:t>
                       </a:r>
                       <a:endParaRPr lang="en-US" sz="1100" dirty="0">
                         <a:latin typeface="Arial" charset="0"/>
@@ -9942,7 +9909,7 @@
                           <a:ea typeface="Arial" pitchFamily="34" charset="-122"/>
                           <a:cs typeface="Arial" pitchFamily="34" charset="-120"/>
                         </a:rPr>
-                        <a:t>      Refinement</a:t>
+                        <a:t>      Refinement, final correction (mapping_A)</a:t>
                       </a:r>
                       <a:endParaRPr lang="en-US" sz="1100" dirty="0">
                         <a:latin typeface="Arial" charset="0"/>
@@ -9983,7 +9950,7 @@
                           <a:ea typeface="Arial" pitchFamily="34" charset="-122"/>
                           <a:cs typeface="Arial" pitchFamily="34" charset="-120"/>
                         </a:rPr>
-                        <a:t>final pose correction</a:t>
+                        <a:t>2 cm</a:t>
                       </a:r>
                       <a:endParaRPr lang="en-US" sz="1100" dirty="0">
                         <a:latin typeface="Arial" charset="0"/>
@@ -10024,7 +9991,7 @@
                           <a:ea typeface="Arial" pitchFamily="34" charset="-122"/>
                           <a:cs typeface="Arial" pitchFamily="34" charset="-120"/>
                         </a:rPr>
-                        <a:t>0.15 cm, 0.017 deg (133x)</a:t>
+                        <a:t>0.15 cm, 0.017 deg</a:t>
                       </a:r>
                       <a:endParaRPr lang="en-US" sz="1100" dirty="0">
                         <a:latin typeface="Arial" charset="0"/>
@@ -10067,7 +10034,7 @@
                           <a:ea typeface="Arial" pitchFamily="34" charset="-122"/>
                           <a:cs typeface="Arial" pitchFamily="34" charset="-120"/>
                         </a:rPr>
-                        <a:t>      Repeatability</a:t>
+                        <a:t>      Repeatability, two maps four weeks apart</a:t>
                       </a:r>
                       <a:endParaRPr lang="en-US" sz="1100" dirty="0">
                         <a:latin typeface="Arial" charset="0"/>
@@ -10108,7 +10075,7 @@
                           <a:ea typeface="Arial" pitchFamily="34" charset="-122"/>
                           <a:cs typeface="Arial" pitchFamily="34" charset="-120"/>
                         </a:rPr>
-                        <a:t>two maps, four weeks apart</a:t>
+                        <a:t>2 cm</a:t>
                       </a:r>
                       <a:endParaRPr lang="en-US" sz="1100" dirty="0">
                         <a:latin typeface="Arial" charset="0"/>
@@ -10149,7 +10116,7 @@
                           <a:ea typeface="Arial" pitchFamily="34" charset="-122"/>
                           <a:cs typeface="Arial" pitchFamily="34" charset="-120"/>
                         </a:rPr>
-                        <a:t>1.06 cm, scale 0.99998 (19x)</a:t>
+                        <a:t>1.06 cm, scale 0.99998</a:t>
                       </a:r>
                       <a:endParaRPr lang="en-US" sz="1100" dirty="0">
                         <a:latin typeface="Arial" charset="0"/>
@@ -10192,7 +10159,7 @@
                           <a:ea typeface="Arial" pitchFamily="34" charset="-122"/>
                           <a:cs typeface="Arial" pitchFamily="34" charset="-120"/>
                         </a:rPr>
-                        <a:t>      Control distances</a:t>
+                        <a:t>      Control distances (rangefinder, per site)</a:t>
                       </a:r>
                       <a:endParaRPr lang="en-US" sz="1100" dirty="0">
                         <a:latin typeface="Arial" charset="0"/>
@@ -10233,7 +10200,7 @@
                           <a:ea typeface="Arial" pitchFamily="34" charset="-122"/>
                           <a:cs typeface="Arial" pitchFamily="34" charset="-120"/>
                         </a:rPr>
-                        <a:t>rangefinder, per site</a:t>
+                        <a:t>2 cm</a:t>
                       </a:r>
                       <a:endParaRPr lang="en-US" sz="1100" dirty="0">
                         <a:latin typeface="Arial" charset="0"/>
@@ -10366,7 +10333,7 @@
                           <a:ea typeface="Arial" pitchFamily="34" charset="-122"/>
                           <a:cs typeface="Arial" pitchFamily="34" charset="-120"/>
                         </a:rPr>
-                        <a:t>      Board detector</a:t>
+                        <a:t>      Board detector vs pipeline, ZED / RealSense</a:t>
                       </a:r>
                       <a:endParaRPr lang="en-US" sz="1100" dirty="0">
                         <a:latin typeface="Arial" charset="0"/>
@@ -10407,7 +10374,7 @@
                           <a:ea typeface="Arial" pitchFamily="34" charset="-122"/>
                           <a:cs typeface="Arial" pitchFamily="34" charset="-120"/>
                         </a:rPr>
-                        <a:t>vs pipeline, ZED / RealSense</a:t>
+                        <a:t>2 cm</a:t>
                       </a:r>
                       <a:endParaRPr lang="en-US" sz="1100" dirty="0">
                         <a:latin typeface="Arial" charset="0"/>
@@ -10448,7 +10415,7 @@
                           <a:ea typeface="Arial" pitchFamily="34" charset="-122"/>
                           <a:cs typeface="Arial" pitchFamily="34" charset="-120"/>
                         </a:rPr>
-                        <a:t>8.1 / 8.3 mm (24x)</a:t>
+                        <a:t>8.1 / 8.3 mm</a:t>
                       </a:r>
                       <a:endParaRPr lang="en-US" sz="1100" dirty="0">
                         <a:latin typeface="Arial" charset="0"/>
@@ -10491,7 +10458,7 @@
                           <a:ea typeface="Arial" pitchFamily="34" charset="-122"/>
                           <a:cs typeface="Arial" pitchFamily="34" charset="-120"/>
                         </a:rPr>
-                        <a:t>      RGB-D cart</a:t>
+                        <a:t>      RGB-D cart vs held-out boards (coop_2)</a:t>
                       </a:r>
                       <a:endParaRPr lang="en-US" sz="1100" dirty="0">
                         <a:latin typeface="Arial" charset="0"/>
@@ -10532,7 +10499,7 @@
                           <a:ea typeface="Arial" pitchFamily="34" charset="-122"/>
                           <a:cs typeface="Arial" pitchFamily="34" charset="-120"/>
                         </a:rPr>
-                        <a:t>held-out boards, coop_2</a:t>
+                        <a:t>2 cm</a:t>
                       </a:r>
                       <a:endParaRPr lang="en-US" sz="1100" dirty="0">
                         <a:latin typeface="Arial" charset="0"/>
@@ -10573,7 +10540,7 @@
                           <a:ea typeface="Arial" pitchFamily="34" charset="-122"/>
                           <a:cs typeface="Arial" pitchFamily="34" charset="-120"/>
                         </a:rPr>
-                        <a:t>3.1 cm (6.5x), sigma 5.3 cm</a:t>
+                        <a:t>3.1 cm median, sigma 5.3 cm</a:t>
                       </a:r>
                       <a:endParaRPr lang="en-US" sz="1100" dirty="0">
                         <a:latin typeface="Arial" charset="0"/>
@@ -10616,7 +10583,7 @@
                           <a:ea typeface="Arial" pitchFamily="34" charset="-122"/>
                           <a:cs typeface="Arial" pitchFamily="34" charset="-120"/>
                         </a:rPr>
-                        <a:t>      LiDAR robot</a:t>
+                        <a:t>      LiDAR robot vs held-out boards (coop2_0828)</a:t>
                       </a:r>
                       <a:endParaRPr lang="en-US" sz="1100" dirty="0">
                         <a:latin typeface="Arial" charset="0"/>
@@ -10657,7 +10624,7 @@
                           <a:ea typeface="Arial" pitchFamily="34" charset="-122"/>
                           <a:cs typeface="Arial" pitchFamily="34" charset="-120"/>
                         </a:rPr>
-                        <a:t>held-out boards, coop2_0828</a:t>
+                        <a:t>2 cm</a:t>
                       </a:r>
                       <a:endParaRPr lang="en-US" sz="1100" dirty="0">
                         <a:latin typeface="Arial" charset="0"/>
@@ -10698,7 +10665,7 @@
                           <a:ea typeface="Arial" pitchFamily="34" charset="-122"/>
                           <a:cs typeface="Arial" pitchFamily="34" charset="-120"/>
                         </a:rPr>
-                        <a:t>10.0 mm, 0.88 deg (20x)</a:t>
+                        <a:t>10.0 mm, 0.88 deg</a:t>
                       </a:r>
                       <a:endParaRPr lang="en-US" sz="1100" dirty="0">
                         <a:latin typeface="Arial" charset="0"/>
@@ -10741,7 +10708,7 @@
                           <a:ea typeface="Arial" pitchFamily="34" charset="-122"/>
                           <a:cs typeface="Arial" pitchFamily="34" charset="-120"/>
                         </a:rPr>
-                        <a:t>      LiDAR robot</a:t>
+                        <a:t>      LiDAR robot vs held-out boards (coop_2)</a:t>
                       </a:r>
                       <a:endParaRPr lang="en-US" sz="1100" dirty="0">
                         <a:latin typeface="Arial" charset="0"/>
@@ -10782,7 +10749,7 @@
                           <a:ea typeface="Arial" pitchFamily="34" charset="-122"/>
                           <a:cs typeface="Arial" pitchFamily="34" charset="-120"/>
                         </a:rPr>
-                        <a:t>held-out boards, coop_2</a:t>
+                        <a:t>2 cm</a:t>
                       </a:r>
                       <a:endParaRPr lang="en-US" sz="1100" dirty="0">
                         <a:latin typeface="Arial" charset="0"/>
@@ -10866,7 +10833,7 @@
                           <a:ea typeface="Arial" pitchFamily="34" charset="-122"/>
                           <a:cs typeface="Arial" pitchFamily="34" charset="-120"/>
                         </a:rPr>
-                        <a:t>      Extrinsics</a:t>
+                        <a:t>      Extrinsics: radar; LiDAR-camera</a:t>
                       </a:r>
                       <a:endParaRPr lang="en-US" sz="1100" dirty="0">
                         <a:latin typeface="Arial" charset="0"/>
@@ -10907,7 +10874,7 @@
                           <a:ea typeface="Arial" pitchFamily="34" charset="-122"/>
                           <a:cs typeface="Arial" pitchFamily="34" charset="-120"/>
                         </a:rPr>
-                        <a:t>radar; LiDAR-camera</a:t>
+                        <a:t>2 cm</a:t>
                       </a:r>
                       <a:endParaRPr lang="en-US" sz="1100" dirty="0">
                         <a:latin typeface="Arial" charset="0"/>
@@ -10991,7 +10958,7 @@
                           <a:ea typeface="Arial" pitchFamily="34" charset="-122"/>
                           <a:cs typeface="Arial" pitchFamily="34" charset="-120"/>
                         </a:rPr>
-                        <a:t>      Agent speed</a:t>
+                        <a:t>      Agent speed, p95 of reference tracks</a:t>
                       </a:r>
                       <a:endParaRPr lang="en-US" sz="1100" dirty="0">
                         <a:latin typeface="Arial" charset="0"/>
@@ -11038,7 +11005,7 @@
                           <a:ea typeface="Arial" pitchFamily="34" charset="-122"/>
                           <a:cs typeface="Arial" pitchFamily="34" charset="-120"/>
                         </a:rPr>
-                        <a:t>p95 of reference tracks</a:t>
+                        <a:t>input</a:t>
                       </a:r>
                       <a:endParaRPr lang="en-US" sz="1100" dirty="0">
                         <a:latin typeface="Arial" charset="0"/>
@@ -11663,7 +11630,7 @@
                 <a:ea typeface="Arial" pitchFamily="34" charset="-122"/>
                 <a:cs typeface="Arial" pitchFamily="34" charset="-120"/>
               </a:rPr>
-              <a:t>Map-derived Fresnel clearance against RSSI with the distance trend removed; pass: rho &gt; 0.3 and clear-minus-obstructed drop &gt; 5 dB</a:t>
+              <a:t>Map-derived Fresnel clearance against RSSI with the distance trend removed</a:t>
             </a:r>
             <a:endParaRPr lang="en-US" sz="1200" dirty="0"/>
           </a:p>
@@ -11692,9 +11659,9 @@
             <a:tbl>
               <a:tblPr/>
               <a:tblGrid>
-                <a:gridCol w="2468880"/>
-                <a:gridCol w="2743200"/>
-                <a:gridCol w="2834640"/>
+                <a:gridCol w="3566160"/>
+                <a:gridCol w="2103120"/>
+                <a:gridCol w="2377440"/>
               </a:tblGrid>
               <a:tr h="210312">
                 <a:tc>
@@ -11756,7 +11723,7 @@
                           <a:ea typeface="Arial" pitchFamily="34" charset="-122"/>
                           <a:cs typeface="Arial" pitchFamily="34" charset="-120"/>
                         </a:rPr>
-                        <a:t>Quantity</a:t>
+                        <a:t>Threshold</a:t>
                       </a:r>
                       <a:endParaRPr lang="en-US" sz="1100" dirty="0">
                         <a:latin typeface="Arial" charset="0"/>
@@ -11913,7 +11880,7 @@
                           <a:ea typeface="Arial" pitchFamily="34" charset="-122"/>
                           <a:cs typeface="Arial" pitchFamily="34" charset="-120"/>
                         </a:rPr>
-                        <a:t>      mobile_2 to sniffer</a:t>
+                        <a:t>      mobile_2 to sniffer: rho, drop</a:t>
                       </a:r>
                       <a:endParaRPr lang="en-US" sz="1100" dirty="0">
                         <a:latin typeface="Arial" charset="0"/>
@@ -11954,7 +11921,7 @@
                           <a:ea typeface="Arial" pitchFamily="34" charset="-122"/>
                           <a:cs typeface="Arial" pitchFamily="34" charset="-120"/>
                         </a:rPr>
-                        <a:t>Spearman rho, drop</a:t>
+                        <a:t>rho &gt; 0.3, drop &gt; 5 dB</a:t>
                       </a:r>
                       <a:endParaRPr lang="en-US" sz="1100" dirty="0">
                         <a:latin typeface="Arial" charset="0"/>
@@ -12038,7 +12005,7 @@
                           <a:ea typeface="Arial" pitchFamily="34" charset="-122"/>
                           <a:cs typeface="Arial" pitchFamily="34" charset="-120"/>
                         </a:rPr>
-                        <a:t>      infra_1 to sniffer</a:t>
+                        <a:t>      infra_1 to sniffer: rho, drop</a:t>
                       </a:r>
                       <a:endParaRPr lang="en-US" sz="1100" dirty="0">
                         <a:latin typeface="Arial" charset="0"/>
@@ -12079,7 +12046,7 @@
                           <a:ea typeface="Arial" pitchFamily="34" charset="-122"/>
                           <a:cs typeface="Arial" pitchFamily="34" charset="-120"/>
                         </a:rPr>
-                        <a:t>Spearman rho, drop</a:t>
+                        <a:t>rho &gt; 0.3, drop &gt; 5 dB</a:t>
                       </a:r>
                       <a:endParaRPr lang="en-US" sz="1100" dirty="0">
                         <a:latin typeface="Arial" charset="0"/>
@@ -12212,7 +12179,7 @@
                           <a:ea typeface="Arial" pitchFamily="34" charset="-122"/>
                           <a:cs typeface="Arial" pitchFamily="34" charset="-120"/>
                         </a:rPr>
-                        <a:t>      RSSI and goodput</a:t>
+                        <a:t>      RSSI and goodput (needs AP position)</a:t>
                       </a:r>
                       <a:endParaRPr lang="en-US" sz="1100" dirty="0">
                         <a:latin typeface="Arial" charset="0"/>
@@ -12253,7 +12220,7 @@
                           <a:ea typeface="Arial" pitchFamily="34" charset="-122"/>
                           <a:cs typeface="Arial" pitchFamily="34" charset="-120"/>
                         </a:rPr>
-                        <a:t>needs AP position (ap.yaml)</a:t>
+                        <a:t>rho &gt; 0.3, drop &gt; 5 dB</a:t>
                       </a:r>
                       <a:endParaRPr lang="en-US" sz="1100" dirty="0">
                         <a:latin typeface="Arial" charset="0"/>
@@ -12378,7 +12345,7 @@
                           <a:ea typeface="Arial" pitchFamily="34" charset="-122"/>
                           <a:cs typeface="Arial" pitchFamily="34" charset="-120"/>
                         </a:rPr>
-                        <a:t>link_clearance.py --all</a:t>
+                        <a:t>rho &gt; 0.3, drop &gt; 5 dB</a:t>
                       </a:r>
                       <a:endParaRPr lang="en-US" sz="1100" dirty="0">
                         <a:latin typeface="Arial" charset="0"/>
@@ -12511,7 +12478,7 @@
                           <a:ea typeface="Arial" pitchFamily="34" charset="-122"/>
                           <a:cs typeface="Arial" pitchFamily="34" charset="-120"/>
                         </a:rPr>
-                        <a:t>      Self-test</a:t>
+                        <a:t>      Self-test, planted 12 dB wall</a:t>
                       </a:r>
                       <a:endParaRPr lang="en-US" sz="1100" dirty="0">
                         <a:latin typeface="Arial" charset="0"/>
@@ -12552,7 +12519,7 @@
                           <a:ea typeface="Arial" pitchFamily="34" charset="-122"/>
                           <a:cs typeface="Arial" pitchFamily="34" charset="-120"/>
                         </a:rPr>
-                        <a:t>planted 12 dB wall</a:t>
+                        <a:t>recovers 12 dB</a:t>
                       </a:r>
                       <a:endParaRPr lang="en-US" sz="1100" dirty="0">
                         <a:latin typeface="Arial" charset="0"/>
@@ -12593,7 +12560,7 @@
                           <a:ea typeface="Arial" pitchFamily="34" charset="-122"/>
                           <a:cs typeface="Arial" pitchFamily="34" charset="-120"/>
                         </a:rPr>
-                        <a:t>recovered 11.9 dB, rho 0.68</a:t>
+                        <a:t>11.9 dB, rho 0.68</a:t>
                       </a:r>
                       <a:endParaRPr lang="en-US" sz="1100" dirty="0">
                         <a:latin typeface="Arial" charset="0"/>
@@ -12636,7 +12603,7 @@
                           <a:ea typeface="Arial" pitchFamily="34" charset="-122"/>
                           <a:cs typeface="Arial" pitchFamily="34" charset="-120"/>
                         </a:rPr>
-                        <a:t>      Confidence interval</a:t>
+                        <a:t>      Confidence interval on rho</a:t>
                       </a:r>
                       <a:endParaRPr lang="en-US" sz="1100" dirty="0">
                         <a:latin typeface="Arial" charset="0"/>
@@ -12677,7 +12644,7 @@
                           <a:ea typeface="Arial" pitchFamily="34" charset="-122"/>
                           <a:cs typeface="Arial" pitchFamily="34" charset="-120"/>
                         </a:rPr>
-                        <a:t>bootstrap over windows</a:t>
+                        <a:t>lower bound &gt; 0.3</a:t>
                       </a:r>
                       <a:endParaRPr lang="en-US" sz="1100" dirty="0">
                         <a:latin typeface="Arial" charset="0"/>
@@ -12761,7 +12728,7 @@
                           <a:ea typeface="Arial" pitchFamily="34" charset="-122"/>
                           <a:cs typeface="Arial" pitchFamily="34" charset="-120"/>
                         </a:rPr>
-                        <a:t>      Out-of-run prediction</a:t>
+                        <a:t>      Out-of-run prediction (fit survey_1, score coop_2)</a:t>
                       </a:r>
                       <a:endParaRPr lang="en-US" sz="1100" dirty="0">
                         <a:latin typeface="Arial" charset="0"/>
@@ -12802,7 +12769,7 @@
                           <a:ea typeface="Arial" pitchFamily="34" charset="-122"/>
                           <a:cs typeface="Arial" pitchFamily="34" charset="-120"/>
                         </a:rPr>
-                        <a:t>fit survey_1, score coop_2</a:t>
+                        <a:t>rho &gt; 0.3</a:t>
                       </a:r>
                       <a:endParaRPr lang="en-US" sz="1100" dirty="0">
                         <a:latin typeface="Arial" charset="0"/>
@@ -12886,7 +12853,7 @@
                           <a:ea typeface="Arial" pitchFamily="34" charset="-122"/>
                           <a:cs typeface="Arial" pitchFamily="34" charset="-120"/>
                         </a:rPr>
-                        <a:t>      CSI power</a:t>
+                        <a:t>      CSI power as second signal</a:t>
                       </a:r>
                       <a:endParaRPr lang="en-US" sz="1100" dirty="0">
                         <a:latin typeface="Arial" charset="0"/>
@@ -12933,7 +12900,7 @@
                           <a:ea typeface="Arial" pitchFamily="34" charset="-122"/>
                           <a:cs typeface="Arial" pitchFamily="34" charset="-120"/>
                         </a:rPr>
-                        <a:t>second signal, same test</a:t>
+                        <a:t>same</a:t>
                       </a:r>
                       <a:endParaRPr lang="en-US" sz="1100" dirty="0">
                         <a:latin typeface="Arial" charset="0"/>
@@ -13537,7 +13504,7 @@
                 <a:ea typeface="Arial" pitchFamily="34" charset="-122"/>
                 <a:cs typeface="Arial" pitchFamily="34" charset="-120"/>
               </a:rPr>
-              <a:t>Replay against live arrivals; pass: at least 90 % agreement on the receiver frame, closer than the synthetic channel</a:t>
+              <a:t>Replay against live arrivals on twin runs (A logs the link, B sends stamped messages)</a:t>
             </a:r>
             <a:endParaRPr lang="en-US" sz="1200" dirty="0"/>
           </a:p>
@@ -13566,9 +13533,9 @@
             <a:tbl>
               <a:tblPr/>
               <a:tblGrid>
-                <a:gridCol w="2468880"/>
+                <a:gridCol w="3108960"/>
+                <a:gridCol w="2194560"/>
                 <a:gridCol w="2743200"/>
-                <a:gridCol w="2834640"/>
               </a:tblGrid>
               <a:tr h="210312">
                 <a:tc>
@@ -13630,7 +13597,7 @@
                           <a:ea typeface="Arial" pitchFamily="34" charset="-122"/>
                           <a:cs typeface="Arial" pitchFamily="34" charset="-120"/>
                         </a:rPr>
-                        <a:t>Quantity</a:t>
+                        <a:t>Threshold</a:t>
                       </a:r>
                       <a:endParaRPr lang="en-US" sz="1100" dirty="0">
                         <a:latin typeface="Arial" charset="0"/>
@@ -13787,7 +13754,7 @@
                           <a:ea typeface="Arial" pitchFamily="34" charset="-122"/>
                           <a:cs typeface="Arial" pitchFamily="34" charset="-120"/>
                         </a:rPr>
-                        <a:t>      Arrival rule</a:t>
+                        <a:t>      Arrival rule d(t) + s/G(t), drop in outage</a:t>
                       </a:r>
                       <a:endParaRPr lang="en-US" sz="1100" dirty="0">
                         <a:latin typeface="Arial" charset="0"/>
@@ -13819,17 +13786,6 @@
                       <a:pPr indent="0" marL="0">
                         <a:buNone/>
                       </a:pPr>
-                      <a:r>
-                        <a:rPr lang="en-US" sz="1100" dirty="0">
-                          <a:solidFill>
-                            <a:srgbClr val="444444"/>
-                          </a:solidFill>
-                          <a:latin typeface="Arial" pitchFamily="34" charset="0"/>
-                          <a:ea typeface="Arial" pitchFamily="34" charset="-122"/>
-                          <a:cs typeface="Arial" pitchFamily="34" charset="-120"/>
-                        </a:rPr>
-                        <a:t>d(t) + s/G(t), drop in outage</a:t>
-                      </a:r>
                       <a:endParaRPr lang="en-US" sz="1100" dirty="0">
                         <a:latin typeface="Arial" charset="0"/>
                         <a:ea typeface="Arial" charset="0"/>
@@ -13912,7 +13868,7 @@
                           <a:ea typeface="Arial" pitchFamily="34" charset="-122"/>
                           <a:cs typeface="Arial" pitchFamily="34" charset="-120"/>
                         </a:rPr>
-                        <a:t>      Inputs</a:t>
+                        <a:t>      Inputs: goodput, RTT, outages</a:t>
                       </a:r>
                       <a:endParaRPr lang="en-US" sz="1100" dirty="0">
                         <a:latin typeface="Arial" charset="0"/>
@@ -13944,17 +13900,6 @@
                       <a:pPr indent="0" marL="0">
                         <a:buNone/>
                       </a:pPr>
-                      <a:r>
-                        <a:rPr lang="en-US" sz="1100" dirty="0">
-                          <a:solidFill>
-                            <a:srgbClr val="444444"/>
-                          </a:solidFill>
-                          <a:latin typeface="Arial" pitchFamily="34" charset="0"/>
-                          <a:ea typeface="Arial" pitchFamily="34" charset="-122"/>
-                          <a:cs typeface="Arial" pitchFamily="34" charset="-120"/>
-                        </a:rPr>
-                        <a:t>goodput, RTT, outages</a:t>
-                      </a:r>
                       <a:endParaRPr lang="en-US" sz="1100" dirty="0">
                         <a:latin typeface="Arial" charset="0"/>
                         <a:ea typeface="Arial" charset="0"/>
@@ -14037,7 +13982,7 @@
                           <a:ea typeface="Arial" pitchFamily="34" charset="-122"/>
                           <a:cs typeface="Arial" pitchFamily="34" charset="-120"/>
                         </a:rPr>
-                        <a:t>Live comparison</a:t>
+                        <a:t>Live comparison (per size and mode)</a:t>
                       </a:r>
                       <a:endParaRPr lang="en-US" sz="1100" dirty="0">
                         <a:latin typeface="Arial" charset="0"/>
@@ -14086,7 +14031,7 @@
                           <a:ea typeface="Arial" pitchFamily="34" charset="-122"/>
                           <a:cs typeface="Arial" pitchFamily="34" charset="-120"/>
                         </a:rPr>
-                        <a:t>      Payload node</a:t>
+                        <a:t>      Frame agreement</a:t>
                       </a:r>
                       <a:endParaRPr lang="en-US" sz="1100" dirty="0">
                         <a:latin typeface="Arial" charset="0"/>
@@ -14127,7 +14072,7 @@
                           <a:ea typeface="Arial" pitchFamily="34" charset="-122"/>
                           <a:cs typeface="Arial" pitchFamily="34" charset="-120"/>
                         </a:rPr>
-                        <a:t>1 KB / 100 KB / 1.5 MB at 10 Hz, stamped</a:t>
+                        <a:t>&gt;= 90 %</a:t>
                       </a:r>
                       <a:endParaRPr lang="en-US" sz="1100" dirty="0">
                         <a:latin typeface="Arial" charset="0"/>
@@ -14211,7 +14156,7 @@
                           <a:ea typeface="Arial" pitchFamily="34" charset="-122"/>
                           <a:cs typeface="Arial" pitchFamily="34" charset="-120"/>
                         </a:rPr>
-                        <a:t>      Twin runs</a:t>
+                        <a:t>      Arrival-time error, median and p95</a:t>
                       </a:r>
                       <a:endParaRPr lang="en-US" sz="1100" dirty="0">
                         <a:latin typeface="Arial" charset="0"/>
@@ -14252,7 +14197,7 @@
                           <a:ea typeface="Arial" pitchFamily="34" charset="-122"/>
                           <a:cs typeface="Arial" pitchFamily="34" charset="-120"/>
                         </a:rPr>
-                        <a:t>A1/B1 survey, A2/B2 cooperation</a:t>
+                        <a:t>below synthetic channel</a:t>
                       </a:r>
                       <a:endParaRPr lang="en-US" sz="1100" dirty="0">
                         <a:latin typeface="Arial" charset="0"/>
@@ -14336,7 +14281,7 @@
                           <a:ea typeface="Arial" pitchFamily="34" charset="-122"/>
                           <a:cs typeface="Arial" pitchFamily="34" charset="-120"/>
                         </a:rPr>
-                        <a:t>      Arrival-time error</a:t>
+                        <a:t>      Drop agreement</a:t>
                       </a:r>
                       <a:endParaRPr lang="en-US" sz="1100" dirty="0">
                         <a:latin typeface="Arial" charset="0"/>
@@ -14368,17 +14313,6 @@
                       <a:pPr indent="0" marL="0">
                         <a:buNone/>
                       </a:pPr>
-                      <a:r>
-                        <a:rPr lang="en-US" sz="1100" dirty="0">
-                          <a:solidFill>
-                            <a:srgbClr val="444444"/>
-                          </a:solidFill>
-                          <a:latin typeface="Arial" pitchFamily="34" charset="0"/>
-                          <a:ea typeface="Arial" pitchFamily="34" charset="-122"/>
-                          <a:cs typeface="Arial" pitchFamily="34" charset="-120"/>
-                        </a:rPr>
-                        <a:t>median, p95 per size and mode</a:t>
-                      </a:r>
                       <a:endParaRPr lang="en-US" sz="1100" dirty="0">
                         <a:latin typeface="Arial" charset="0"/>
                         <a:ea typeface="Arial" charset="0"/>
@@ -14461,7 +14395,7 @@
                           <a:ea typeface="Arial" pitchFamily="34" charset="-122"/>
                           <a:cs typeface="Arial" pitchFamily="34" charset="-120"/>
                         </a:rPr>
-                        <a:t>      Frame agreement</a:t>
+                        <a:t>      Payload node and twin runs</a:t>
                       </a:r>
                       <a:endParaRPr lang="en-US" sz="1100" dirty="0">
                         <a:latin typeface="Arial" charset="0"/>
@@ -14480,8 +14414,14 @@
                     <a:lnT w="0" cap="flat" cmpd="sng" algn="ctr">
                       <a:noFill/>
                     </a:lnT>
-                    <a:lnB w="0" cap="flat" cmpd="sng" algn="ctr">
-                      <a:noFill/>
+                    <a:lnB w="15875" cap="flat" cmpd="sng" algn="ctr">
+                      <a:solidFill>
+                        <a:srgbClr val="333333"/>
+                      </a:solidFill>
+                      <a:prstDash val="solid"/>
+                      <a:round/>
+                      <a:headEnd type="none" w="med" len="med"/>
+                      <a:tailEnd type="none" w="med" len="med"/>
                     </a:lnB>
                   </a:tcPr>
                 </a:tc>
@@ -14502,138 +14442,7 @@
                           <a:ea typeface="Arial" pitchFamily="34" charset="-122"/>
                           <a:cs typeface="Arial" pitchFamily="34" charset="-120"/>
                         </a:rPr>
-                        <a:t>share landing in the same 100 ms frame</a:t>
-                      </a:r>
-                      <a:endParaRPr lang="en-US" sz="1100" dirty="0">
-                        <a:latin typeface="Arial" charset="0"/>
-                        <a:ea typeface="Arial" charset="0"/>
-                        <a:cs typeface="Arial" charset="0"/>
-                      </a:endParaRPr>
-                    </a:p>
-                  </a:txBody>
-                  <a:tcPr marL="18288" marR="18288" marT="18288" marB="18288" anchor="ctr">
-                    <a:lnL w="0" cap="flat" cmpd="sng" algn="ctr">
-                      <a:noFill/>
-                    </a:lnL>
-                    <a:lnR w="0" cap="flat" cmpd="sng" algn="ctr">
-                      <a:noFill/>
-                    </a:lnR>
-                    <a:lnT w="0" cap="flat" cmpd="sng" algn="ctr">
-                      <a:noFill/>
-                    </a:lnT>
-                    <a:lnB w="0" cap="flat" cmpd="sng" algn="ctr">
-                      <a:noFill/>
-                    </a:lnB>
-                  </a:tcPr>
-                </a:tc>
-                <a:tc>
-                  <a:txBody>
-                    <a:bodyPr/>
-                    <a:lstStyle/>
-                    <a:p>
-                      <a:pPr indent="0" marL="0">
-                        <a:buNone/>
-                      </a:pPr>
-                      <a:r>
-                        <a:rPr lang="en-US" sz="1100" dirty="0">
-                          <a:solidFill>
-                            <a:srgbClr val="7F8C8D"/>
-                          </a:solidFill>
-                          <a:latin typeface="Arial" pitchFamily="34" charset="0"/>
-                          <a:ea typeface="Arial" pitchFamily="34" charset="-122"/>
-                          <a:cs typeface="Arial" pitchFamily="34" charset="-120"/>
-                        </a:rPr>
-                        <a:t>--</a:t>
-                      </a:r>
-                      <a:endParaRPr lang="en-US" sz="1100" dirty="0">
-                        <a:latin typeface="Arial" charset="0"/>
-                        <a:ea typeface="Arial" charset="0"/>
-                        <a:cs typeface="Arial" charset="0"/>
-                      </a:endParaRPr>
-                    </a:p>
-                  </a:txBody>
-                  <a:tcPr marL="18288" marR="18288" marT="18288" marB="18288" anchor="ctr">
-                    <a:lnL w="0" cap="flat" cmpd="sng" algn="ctr">
-                      <a:noFill/>
-                    </a:lnL>
-                    <a:lnR w="0" cap="flat" cmpd="sng" algn="ctr">
-                      <a:noFill/>
-                    </a:lnR>
-                    <a:lnT w="0" cap="flat" cmpd="sng" algn="ctr">
-                      <a:noFill/>
-                    </a:lnT>
-                    <a:lnB w="0" cap="flat" cmpd="sng" algn="ctr">
-                      <a:noFill/>
-                    </a:lnB>
-                  </a:tcPr>
-                </a:tc>
-              </a:tr>
-              <a:tr h="210312">
-                <a:tc>
-                  <a:txBody>
-                    <a:bodyPr/>
-                    <a:lstStyle/>
-                    <a:p>
-                      <a:pPr indent="0" marL="0">
-                        <a:buNone/>
-                      </a:pPr>
-                      <a:r>
-                        <a:rPr lang="en-US" sz="1100" dirty="0">
-                          <a:solidFill>
-                            <a:srgbClr val="222222"/>
-                          </a:solidFill>
-                          <a:latin typeface="Arial" pitchFamily="34" charset="0"/>
-                          <a:ea typeface="Arial" pitchFamily="34" charset="-122"/>
-                          <a:cs typeface="Arial" pitchFamily="34" charset="-120"/>
-                        </a:rPr>
-                        <a:t>      Drop agreement</a:t>
-                      </a:r>
-                      <a:endParaRPr lang="en-US" sz="1100" dirty="0">
-                        <a:latin typeface="Arial" charset="0"/>
-                        <a:ea typeface="Arial" charset="0"/>
-                        <a:cs typeface="Arial" charset="0"/>
-                      </a:endParaRPr>
-                    </a:p>
-                  </a:txBody>
-                  <a:tcPr marL="18288" marR="18288" marT="18288" marB="18288" anchor="ctr">
-                    <a:lnL w="0" cap="flat" cmpd="sng" algn="ctr">
-                      <a:noFill/>
-                    </a:lnL>
-                    <a:lnR w="0" cap="flat" cmpd="sng" algn="ctr">
-                      <a:noFill/>
-                    </a:lnR>
-                    <a:lnT w="0" cap="flat" cmpd="sng" algn="ctr">
-                      <a:noFill/>
-                    </a:lnT>
-                    <a:lnB w="15875" cap="flat" cmpd="sng" algn="ctr">
-                      <a:solidFill>
-                        <a:srgbClr val="333333"/>
-                      </a:solidFill>
-                      <a:prstDash val="solid"/>
-                      <a:round/>
-                      <a:headEnd type="none" w="med" len="med"/>
-                      <a:tailEnd type="none" w="med" len="med"/>
-                    </a:lnB>
-                  </a:tcPr>
-                </a:tc>
-                <a:tc>
-                  <a:txBody>
-                    <a:bodyPr/>
-                    <a:lstStyle/>
-                    <a:p>
-                      <a:pPr indent="0" marL="0">
-                        <a:buNone/>
-                      </a:pPr>
-                      <a:r>
-                        <a:rPr lang="en-US" sz="1100" dirty="0">
-                          <a:solidFill>
-                            <a:srgbClr val="444444"/>
-                          </a:solidFill>
-                          <a:latin typeface="Arial" pitchFamily="34" charset="0"/>
-                          <a:ea typeface="Arial" pitchFamily="34" charset="-122"/>
-                          <a:cs typeface="Arial" pitchFamily="34" charset="-120"/>
-                        </a:rPr>
-                        <a:t>per size and mode</a:t>
+                        <a:t>A1/B1 survey, A2/B2 coop</a:t>
                       </a:r>
                       <a:endParaRPr lang="en-US" sz="1100" dirty="0">
                         <a:latin typeface="Arial" charset="0"/>
@@ -15279,7 +15088,7 @@
                 <a:ea typeface="Arial" pitchFamily="34" charset="-122"/>
                 <a:cs typeface="Arial" pitchFamily="34" charset="-120"/>
               </a:rPr>
-              <a:t>Pass: day-to-day distance below half the survey-to-cooperation distance, for RTT and goodput</a:t>
+              <a:t>Same setting, another day</a:t>
             </a:r>
             <a:endParaRPr lang="en-US" sz="1200" dirty="0"/>
           </a:p>
@@ -15308,9 +15117,9 @@
             <a:tbl>
               <a:tblPr/>
               <a:tblGrid>
-                <a:gridCol w="2468880"/>
+                <a:gridCol w="3108960"/>
+                <a:gridCol w="2194560"/>
                 <a:gridCol w="2743200"/>
-                <a:gridCol w="2834640"/>
               </a:tblGrid>
               <a:tr h="210312">
                 <a:tc>
@@ -15372,7 +15181,7 @@
                           <a:ea typeface="Arial" pitchFamily="34" charset="-122"/>
                           <a:cs typeface="Arial" pitchFamily="34" charset="-120"/>
                         </a:rPr>
-                        <a:t>Quantity</a:t>
+                        <a:t>Threshold</a:t>
                       </a:r>
                       <a:endParaRPr lang="en-US" sz="1100" dirty="0">
                         <a:latin typeface="Arial" charset="0"/>
@@ -15529,7 +15338,7 @@
                           <a:ea typeface="Arial" pitchFamily="34" charset="-122"/>
                           <a:cs typeface="Arial" pitchFamily="34" charset="-120"/>
                         </a:rPr>
-                        <a:t>      Frame across days</a:t>
+                        <a:t>      Frame across days, two maps four weeks apart</a:t>
                       </a:r>
                       <a:endParaRPr lang="en-US" sz="1100" dirty="0">
                         <a:latin typeface="Arial" charset="0"/>
@@ -15570,7 +15379,7 @@
                           <a:ea typeface="Arial" pitchFamily="34" charset="-122"/>
                           <a:cs typeface="Arial" pitchFamily="34" charset="-120"/>
                         </a:rPr>
-                        <a:t>two maps, four weeks apart</a:t>
+                        <a:t>2 cm</a:t>
                       </a:r>
                       <a:endParaRPr lang="en-US" sz="1100" dirty="0">
                         <a:latin typeface="Arial" charset="0"/>
@@ -15703,7 +15512,7 @@
                           <a:ea typeface="Arial" pitchFamily="34" charset="-122"/>
                           <a:cs typeface="Arial" pitchFamily="34" charset="-120"/>
                         </a:rPr>
-                        <a:t>      Mode distance</a:t>
+                        <a:t>      Mode distance, survey_1 vs coop_2 (W1, KS)</a:t>
                       </a:r>
                       <a:endParaRPr lang="en-US" sz="1100" dirty="0">
                         <a:latin typeface="Arial" charset="0"/>
@@ -15744,7 +15553,7 @@
                           <a:ea typeface="Arial" pitchFamily="34" charset="-122"/>
                           <a:cs typeface="Arial" pitchFamily="34" charset="-120"/>
                         </a:rPr>
-                        <a:t>survey_1 vs coop_2, W1 and KS</a:t>
+                        <a:t>reference</a:t>
                       </a:r>
                       <a:endParaRPr lang="en-US" sz="1100" dirty="0">
                         <a:latin typeface="Arial" charset="0"/>
@@ -15828,7 +15637,7 @@
                           <a:ea typeface="Arial" pitchFamily="34" charset="-122"/>
                           <a:cs typeface="Arial" pitchFamily="34" charset="-120"/>
                         </a:rPr>
-                        <a:t>      Day distance</a:t>
+                        <a:t>      Day distance, same route and mode</a:t>
                       </a:r>
                       <a:endParaRPr lang="en-US" sz="1100" dirty="0">
                         <a:latin typeface="Arial" charset="0"/>
@@ -15860,17 +15669,6 @@
                       <a:pPr indent="0" marL="0">
                         <a:buNone/>
                       </a:pPr>
-                      <a:r>
-                        <a:rPr lang="en-US" sz="1100" dirty="0">
-                          <a:solidFill>
-                            <a:srgbClr val="444444"/>
-                          </a:solidFill>
-                          <a:latin typeface="Arial" pitchFamily="34" charset="0"/>
-                          <a:ea typeface="Arial" pitchFamily="34" charset="-122"/>
-                          <a:cs typeface="Arial" pitchFamily="34" charset="-120"/>
-                        </a:rPr>
-                        <a:t>same route and mode, second day</a:t>
-                      </a:r>
                       <a:endParaRPr lang="en-US" sz="1100" dirty="0">
                         <a:latin typeface="Arial" charset="0"/>
                         <a:ea typeface="Arial" charset="0"/>
@@ -15953,7 +15751,7 @@
                           <a:ea typeface="Arial" pitchFamily="34" charset="-122"/>
                           <a:cs typeface="Arial" pitchFamily="34" charset="-120"/>
                         </a:rPr>
-                        <a:t>      Day / mode ratio</a:t>
+                        <a:t>      Day / mode ratio, RTT and goodput</a:t>
                       </a:r>
                       <a:endParaRPr lang="en-US" sz="1100" dirty="0">
                         <a:latin typeface="Arial" charset="0"/>
@@ -16000,7 +15798,7 @@
                           <a:ea typeface="Arial" pitchFamily="34" charset="-122"/>
                           <a:cs typeface="Arial" pitchFamily="34" charset="-120"/>
                         </a:rPr>
-                        <a:t>RTT and goodput, pass &lt; 0.5</a:t>
+                        <a:t>&lt; 0.5</a:t>
                       </a:r>
                       <a:endParaRPr lang="en-US" sz="1100" dirty="0">
                         <a:latin typeface="Arial" charset="0"/>

</xml_diff>